<commit_message>
Schedule page becomes Overview
Co-Authored-By: Claude Opus 5.5 <noreply@anthropic.com>
Claude-Session: https://claude.ai/code/session_012sjsUQBbC7zon57rWHoo9d
</commit_message>
<xml_diff>
--- a/slides/00 Course Intro.pptx
+++ b/slides/00 Course Intro.pptx
@@ -1103,7 +1103,7 @@
           <a:lstStyle/>
           <a:p>
             <a:r>
-              <a:t>Open the site and show the schedule, the project page and the exam page. Then gar-games and the starter template.</a:t>
+              <a:t>Open the site and show the overview, the project page and the exam page. Then gar-games and the starter template.</a:t>
             </a:r>
           </a:p>
           <a:p>
@@ -1652,7 +1652,7 @@
           <a:lstStyle/>
           <a:p>
             <a:r>
-              <a:t>Each session has one main topic and a few patterns that go with it. The schedule lists both.</a:t>
+              <a:t>Each session has one main topic and a few patterns that go with it. The overview page lists both.</a:t>
             </a:r>
           </a:p>
           <a:p>
@@ -1751,7 +1751,7 @@
           </a:p>
           <a:p>
             <a:r>
-              <a:t>The schedule on the site lists each session’s topics.</a:t>
+              <a:t>The overview page on the site lists each session’s topics.</a:t>
             </a:r>
           </a:p>
         </p:txBody>
@@ -6372,7 +6372,7 @@
             </a:pPr>
             <a:r>
               <a:rPr lang="en"/>
-              <a:t>The course site: sessions, schedule, project and exam</a:t>
+              <a:t>The course site: sessions, overview, project and exam</a:t>
             </a:r>
             <a:endParaRPr/>
           </a:p>

</xml_diff>

<commit_message>
Decks and Pong page: borrowed pictures replaced with our own figures
Nineteen new figures (game loop, MonoGame lifecycle, texture filtering,
encapsulation, update method, Pong modes, change cycle, class library,
Flappy states, singleton, collision response, broad and narrow phase,
four for the Command pattern, observer, a generated room, shader pipeline)
take the place of pictures from other courses, books and sites.
Eight slides that only carried such a picture are gone.

Co-Authored-By: Claude Opus 5.5 <noreply@anthropic.com>
Claude-Session: https://claude.ai/code/session_012sjsUQBbC7zon57rWHoo9d
</commit_message>
<xml_diff>
--- a/slides/00 Course Intro.pptx
+++ b/slides/00 Course Intro.pptx
@@ -6731,34 +6731,6 @@
           </a:p>
         </p:txBody>
       </p:sp>
-      <p:pic>
-        <p:nvPicPr>
-          <p:cNvPr id="54" name="Google Shape;54;p11"/>
-          <p:cNvPicPr preferRelativeResize="0"/>
-          <p:nvPr/>
-        </p:nvPicPr>
-        <p:blipFill>
-          <a:blip r:embed="rId3">
-            <a:alphaModFix/>
-          </a:blip>
-          <a:stretch>
-            <a:fillRect/>
-          </a:stretch>
-        </p:blipFill>
-        <p:spPr>
-          <a:xfrm>
-            <a:off x="2385650" y="1563194"/>
-            <a:ext cx="4372700" cy="2450901"/>
-          </a:xfrm>
-          <a:prstGeom prst="rect">
-            <a:avLst/>
-          </a:prstGeom>
-          <a:noFill/>
-          <a:ln>
-            <a:noFill/>
-          </a:ln>
-        </p:spPr>
-      </p:pic>
     </p:spTree>
   </p:cSld>
   <p:clrMapOvr>
@@ -7780,34 +7752,6 @@
           <a:chExt cx="0" cy="0"/>
         </a:xfrm>
       </p:grpSpPr>
-      <p:pic>
-        <p:nvPicPr>
-          <p:cNvPr id="88" name="Google Shape;88;p17"/>
-          <p:cNvPicPr preferRelativeResize="0"/>
-          <p:nvPr/>
-        </p:nvPicPr>
-        <p:blipFill>
-          <a:blip r:embed="rId3">
-            <a:alphaModFix/>
-          </a:blip>
-          <a:stretch>
-            <a:fillRect/>
-          </a:stretch>
-        </p:blipFill>
-        <p:spPr>
-          <a:xfrm>
-            <a:off x="3013825" y="533775"/>
-            <a:ext cx="3116351" cy="3842575"/>
-          </a:xfrm>
-          <a:prstGeom prst="rect">
-            <a:avLst/>
-          </a:prstGeom>
-          <a:noFill/>
-          <a:ln>
-            <a:noFill/>
-          </a:ln>
-        </p:spPr>
-      </p:pic>
       <p:sp>
         <p:nvSpPr>
           <p:cNvPr id="89" name="Google Shape;89;p17"/>
@@ -7864,6 +7808,74 @@
               <a:cs typeface="Roboto Light"/>
               <a:sym typeface="Roboto Light"/>
             </a:endParaRPr>
+          </a:p>
+        </p:txBody>
+      </p:sp>
+      <p:sp>
+        <p:nvSpPr>
+          <p:cNvPr id="90" name="TextBox 89"/>
+          <p:cNvSpPr txBox="1"/>
+          <p:nvPr/>
+        </p:nvSpPr>
+        <p:spPr>
+          <a:xfrm>
+            <a:off x="457200" y="1920240"/>
+            <a:ext cx="8229600" cy="457200"/>
+          </a:xfrm>
+          <a:prstGeom prst="rect">
+            <a:avLst/>
+          </a:prstGeom>
+          <a:noFill/>
+        </p:spPr>
+        <p:txBody>
+          <a:bodyPr wrap="square">
+            <a:spAutoFit/>
+          </a:bodyPr>
+          <a:lstStyle/>
+          <a:p>
+            <a:pPr algn="ctr"/>
+            <a:r>
+              <a:rPr sz="2200" b="0" i="0">
+                <a:solidFill>
+                  <a:srgbClr val="DEE2E6"/>
+                </a:solidFill>
+              </a:rPr>
+              <a:t>Game Programming Patterns</a:t>
+            </a:r>
+          </a:p>
+        </p:txBody>
+      </p:sp>
+      <p:sp>
+        <p:nvSpPr>
+          <p:cNvPr id="91" name="TextBox 90"/>
+          <p:cNvSpPr txBox="1"/>
+          <p:nvPr/>
+        </p:nvSpPr>
+        <p:spPr>
+          <a:xfrm>
+            <a:off x="457200" y="2468880"/>
+            <a:ext cx="8229600" cy="457200"/>
+          </a:xfrm>
+          <a:prstGeom prst="rect">
+            <a:avLst/>
+          </a:prstGeom>
+          <a:noFill/>
+        </p:spPr>
+        <p:txBody>
+          <a:bodyPr wrap="square">
+            <a:spAutoFit/>
+          </a:bodyPr>
+          <a:lstStyle/>
+          <a:p>
+            <a:pPr algn="ctr"/>
+            <a:r>
+              <a:rPr sz="1800" b="0" i="0">
+                <a:solidFill>
+                  <a:srgbClr val="9AA3AB"/>
+                </a:solidFill>
+              </a:rPr>
+              <a:t>Robert Nystrom</a:t>
+            </a:r>
           </a:p>
         </p:txBody>
       </p:sp>

</xml_diff>

<commit_message>
Decks: exercise slides follow the pages, and two bare slides have their content
Co-Authored-By: Claude Opus 5.5 <noreply@anthropic.com>
Claude-Session: https://claude.ai/code/session_012sjsUQBbC7zon57rWHoo9d
</commit_message>
<xml_diff>
--- a/slides/00 Course Intro.pptx
+++ b/slides/00 Course Intro.pptx
@@ -10,7 +10,7 @@
   <p:sldIdLst>
     <p:sldId id="256" r:id="rId6"/>
     <p:sldId id="257" r:id="rId7"/>
-    <p:sldId id="258" r:id="rId8"/>
+    <p:sldId id="269" r:id="rId28"/>
     <p:sldId id="259" r:id="rId9"/>
     <p:sldId id="260" r:id="rId10"/>
     <p:sldId id="261" r:id="rId11"/>
@@ -1121,6 +1121,69 @@
 </p:notes>
 </file>
 
+<file path=ppt/notesSlides/notesSlide14.xml><?xml version="1.0" encoding="utf-8"?>
+<p:notes xmlns:a="http://schemas.openxmlformats.org/drawingml/2006/main" xmlns:p="http://schemas.openxmlformats.org/presentationml/2006/main" xmlns:r="http://schemas.openxmlformats.org/officeDocument/2006/relationships">
+  <p:cSld>
+    <p:spTree>
+      <p:nvGrpSpPr>
+        <p:cNvPr id="1" name=""/>
+        <p:cNvGrpSpPr/>
+        <p:nvPr/>
+      </p:nvGrpSpPr>
+      <p:grpSpPr>
+        <a:xfrm>
+          <a:off x="0" y="0"/>
+          <a:ext cx="0" cy="0"/>
+          <a:chOff x="0" y="0"/>
+          <a:chExt cx="0" cy="0"/>
+        </a:xfrm>
+      </p:grpSpPr>
+      <p:sp>
+        <p:nvSpPr>
+          <p:cNvPr id="2" name="Slide Image Placeholder 1"/>
+          <p:cNvSpPr>
+            <a:spLocks noGrp="1"/>
+          </p:cNvSpPr>
+          <p:nvPr>
+            <p:ph type="sldImg" idx="2"/>
+          </p:nvPr>
+        </p:nvSpPr>
+        <p:spPr/>
+      </p:sp>
+      <p:sp>
+        <p:nvSpPr>
+          <p:cNvPr id="3" name="Notes Placeholder 2"/>
+          <p:cNvSpPr>
+            <a:spLocks noGrp="1"/>
+          </p:cNvSpPr>
+          <p:nvPr>
+            <p:ph type="body" idx="1"/>
+          </p:nvPr>
+        </p:nvSpPr>
+        <p:spPr/>
+        <p:txBody>
+          <a:bodyPr/>
+          <a:lstStyle/>
+          <a:p>
+            <a:r>
+              <a:t>Go round the room: name, study line, a game you’ve played a lot, and whether you’ve made a game before.</a:t>
+            </a:r>
+          </a:p>
+          <a:p>
+            <a:r>
+              <a:t>Note who has made games before; they make good group anchors.</a:t>
+            </a:r>
+          </a:p>
+        </p:txBody>
+      </p:sp>
+    </p:spTree>
+  </p:cSld>
+  <p:clrMapOvr>
+    <a:masterClrMapping/>
+  </p:clrMapOvr>
+</p:notes>
+</file>
+
 <file path=ppt/notesSlides/notesSlide2.xml><?xml version="1.0" encoding="utf-8"?>
 <p:notes xmlns:a="http://schemas.openxmlformats.org/drawingml/2006/main" xmlns:r="http://schemas.openxmlformats.org/officeDocument/2006/relationships" xmlns:mc="http://schemas.openxmlformats.org/markup-compatibility/2006" xmlns:mv="urn:schemas-microsoft-com:mac:vml" xmlns:p="http://schemas.openxmlformats.org/presentationml/2006/main" xmlns:c="http://schemas.openxmlformats.org/drawingml/2006/chart" xmlns:dgm="http://schemas.openxmlformats.org/drawingml/2006/diagram" xmlns:o="urn:schemas-microsoft-com:office:office" xmlns:v="urn:schemas-microsoft-com:vml" xmlns:pvml="urn:schemas-microsoft-com:office:powerpoint" xmlns:com="http://schemas.openxmlformats.org/drawingml/2006/compatibility" xmlns:p14="http://schemas.microsoft.com/office/powerpoint/2010/main" xmlns:p15="http://schemas.microsoft.com/office/powerpoint/2012/main" xmlns:ahyp="http://schemas.microsoft.com/office/drawing/2018/hyperlinkcolor" showMasterPhAnim="0" showMasterSp="0">
   <p:cSld>
@@ -1198,100 +1261,6 @@
           <a:p>
             <a:r>
               <a:t>A short introduction: background, what I work on, how to reach me. Keep it to a minute.</a:t>
-            </a:r>
-          </a:p>
-        </p:txBody>
-      </p:sp>
-    </p:spTree>
-  </p:cSld>
-  <p:clrMapOvr>
-    <a:masterClrMapping/>
-  </p:clrMapOvr>
-</p:notes>
-</file>
-
-<file path=ppt/notesSlides/notesSlide3.xml><?xml version="1.0" encoding="utf-8"?>
-<p:notes xmlns:a="http://schemas.openxmlformats.org/drawingml/2006/main" xmlns:r="http://schemas.openxmlformats.org/officeDocument/2006/relationships" xmlns:mc="http://schemas.openxmlformats.org/markup-compatibility/2006" xmlns:mv="urn:schemas-microsoft-com:mac:vml" xmlns:p="http://schemas.openxmlformats.org/presentationml/2006/main" xmlns:c="http://schemas.openxmlformats.org/drawingml/2006/chart" xmlns:dgm="http://schemas.openxmlformats.org/drawingml/2006/diagram" xmlns:o="urn:schemas-microsoft-com:office:office" xmlns:v="urn:schemas-microsoft-com:vml" xmlns:pvml="urn:schemas-microsoft-com:office:powerpoint" xmlns:com="http://schemas.openxmlformats.org/drawingml/2006/compatibility" xmlns:p14="http://schemas.microsoft.com/office/powerpoint/2010/main" xmlns:p15="http://schemas.microsoft.com/office/powerpoint/2012/main" xmlns:ahyp="http://schemas.microsoft.com/office/drawing/2018/hyperlinkcolor" showMasterPhAnim="0" showMasterSp="0">
-  <p:cSld>
-    <p:spTree>
-      <p:nvGrpSpPr>
-        <p:cNvPr id="49" name="Shape 49"/>
-        <p:cNvGrpSpPr/>
-        <p:nvPr/>
-      </p:nvGrpSpPr>
-      <p:grpSpPr>
-        <a:xfrm>
-          <a:off x="0" y="0"/>
-          <a:ext cx="0" cy="0"/>
-          <a:chOff x="0" y="0"/>
-          <a:chExt cx="0" cy="0"/>
-        </a:xfrm>
-      </p:grpSpPr>
-      <p:sp>
-        <p:nvSpPr>
-          <p:cNvPr id="50" name="Google Shape;50;g3932a601320_0_124:notes"/>
-          <p:cNvSpPr/>
-          <p:nvPr>
-            <p:ph idx="2" type="sldImg"/>
-          </p:nvPr>
-        </p:nvSpPr>
-        <p:spPr>
-          <a:xfrm>
-            <a:off x="381300" y="685800"/>
-            <a:ext cx="6096000" cy="3429000"/>
-          </a:xfrm>
-          <a:custGeom>
-            <a:rect b="b" l="l" r="r" t="t"/>
-            <a:pathLst>
-              <a:path extrusionOk="0" h="120000" w="120000">
-                <a:moveTo>
-                  <a:pt x="0" y="0"/>
-                </a:moveTo>
-                <a:lnTo>
-                  <a:pt x="120000" y="0"/>
-                </a:lnTo>
-                <a:lnTo>
-                  <a:pt x="120000" y="120000"/>
-                </a:lnTo>
-                <a:lnTo>
-                  <a:pt x="0" y="120000"/>
-                </a:lnTo>
-                <a:close/>
-              </a:path>
-            </a:pathLst>
-          </a:custGeom>
-        </p:spPr>
-      </p:sp>
-      <p:sp>
-        <p:nvSpPr>
-          <p:cNvPr id="51" name="Google Shape;51;g3932a601320_0_124:notes"/>
-          <p:cNvSpPr txBox="1"/>
-          <p:nvPr>
-            <p:ph idx="1" type="body"/>
-          </p:nvPr>
-        </p:nvSpPr>
-        <p:spPr>
-          <a:xfrm>
-            <a:off x="685800" y="4343400"/>
-            <a:ext cx="5486400" cy="4114800"/>
-          </a:xfrm>
-          <a:prstGeom prst="rect">
-            <a:avLst/>
-          </a:prstGeom>
-        </p:spPr>
-        <p:txBody>
-          <a:bodyPr anchorCtr="0" anchor="t" bIns="91425" lIns="91425" spcFirstLastPara="1" rIns="91425" wrap="square" tIns="91425">
-            <a:noAutofit/>
-          </a:bodyPr>
-          <a:lstStyle/>
-          <a:p>
-            <a:r>
-              <a:t>Go round the room: name, study line, a game you’ve played a lot, and whether you’ve made a game before.</a:t>
-            </a:r>
-          </a:p>
-          <a:p>
-            <a:r>
-              <a:t>Note who has made games before; they make good group anchors.</a:t>
             </a:r>
           </a:p>
         </p:txBody>
@@ -5520,6 +5489,158 @@
 </file>
 
 <file path=ppt/slides/slide10.xml><?xml version="1.0" encoding="utf-8"?>
+<p:sld xmlns:a="http://schemas.openxmlformats.org/drawingml/2006/main" xmlns:r="http://schemas.openxmlformats.org/officeDocument/2006/relationships" xmlns:mc="http://schemas.openxmlformats.org/markup-compatibility/2006" xmlns:mv="urn:schemas-microsoft-com:mac:vml" xmlns:p="http://schemas.openxmlformats.org/presentationml/2006/main" xmlns:c="http://schemas.openxmlformats.org/drawingml/2006/chart" xmlns:dgm="http://schemas.openxmlformats.org/drawingml/2006/diagram" xmlns:o="urn:schemas-microsoft-com:office:office" xmlns:v="urn:schemas-microsoft-com:vml" xmlns:pvml="urn:schemas-microsoft-com:office:powerpoint" xmlns:com="http://schemas.openxmlformats.org/drawingml/2006/compatibility" xmlns:p14="http://schemas.microsoft.com/office/powerpoint/2010/main" xmlns:p15="http://schemas.microsoft.com/office/powerpoint/2012/main" xmlns:ahyp="http://schemas.microsoft.com/office/drawing/2018/hyperlinkcolor">
+  <p:cSld>
+    <p:spTree>
+      <p:nvGrpSpPr>
+        <p:cNvPr id="87" name="Shape 87"/>
+        <p:cNvGrpSpPr/>
+        <p:nvPr/>
+      </p:nvGrpSpPr>
+      <p:grpSpPr>
+        <a:xfrm>
+          <a:off x="0" y="0"/>
+          <a:ext cx="0" cy="0"/>
+          <a:chOff x="0" y="0"/>
+          <a:chExt cx="0" cy="0"/>
+        </a:xfrm>
+      </p:grpSpPr>
+      <p:sp>
+        <p:nvSpPr>
+          <p:cNvPr id="89" name="Google Shape;89;p17"/>
+          <p:cNvSpPr txBox="1"/>
+          <p:nvPr/>
+        </p:nvSpPr>
+        <p:spPr>
+          <a:xfrm>
+            <a:off x="3013800" y="4453575"/>
+            <a:ext cx="3116400" cy="391200"/>
+          </a:xfrm>
+          <a:prstGeom prst="rect">
+            <a:avLst/>
+          </a:prstGeom>
+          <a:noFill/>
+          <a:ln>
+            <a:noFill/>
+          </a:ln>
+        </p:spPr>
+        <p:txBody>
+          <a:bodyPr anchorCtr="0" anchor="t" bIns="91425" lIns="91425" spcFirstLastPara="1" rIns="91425" wrap="square" tIns="91425">
+            <a:noAutofit/>
+          </a:bodyPr>
+          <a:lstStyle/>
+          <a:p>
+            <a:pPr indent="0" lvl="0" marL="0" rtl="0" algn="ctr">
+              <a:spcBef>
+                <a:spcPts val="0"/>
+              </a:spcBef>
+              <a:spcAft>
+                <a:spcPts val="0"/>
+              </a:spcAft>
+              <a:buNone/>
+            </a:pPr>
+            <a:r>
+              <a:rPr lang="en" u="sng">
+                <a:solidFill>
+                  <a:schemeClr val="hlink"/>
+                </a:solidFill>
+                <a:latin typeface="Roboto Light"/>
+                <a:ea typeface="Roboto Light"/>
+                <a:cs typeface="Roboto Light"/>
+                <a:sym typeface="Roboto Light"/>
+                <a:hlinkClick r:id="rId4"/>
+              </a:rPr>
+              <a:t>gameprogrammingpatterns.com</a:t>
+            </a:r>
+            <a:endParaRPr>
+              <a:solidFill>
+                <a:schemeClr val="dk1"/>
+              </a:solidFill>
+              <a:latin typeface="Roboto Light"/>
+              <a:ea typeface="Roboto Light"/>
+              <a:cs typeface="Roboto Light"/>
+              <a:sym typeface="Roboto Light"/>
+            </a:endParaRPr>
+          </a:p>
+        </p:txBody>
+      </p:sp>
+      <p:sp>
+        <p:nvSpPr>
+          <p:cNvPr id="90" name="TextBox 89"/>
+          <p:cNvSpPr txBox="1"/>
+          <p:nvPr/>
+        </p:nvSpPr>
+        <p:spPr>
+          <a:xfrm>
+            <a:off x="457200" y="1920240"/>
+            <a:ext cx="8229600" cy="457200"/>
+          </a:xfrm>
+          <a:prstGeom prst="rect">
+            <a:avLst/>
+          </a:prstGeom>
+          <a:noFill/>
+        </p:spPr>
+        <p:txBody>
+          <a:bodyPr wrap="square">
+            <a:spAutoFit/>
+          </a:bodyPr>
+          <a:lstStyle/>
+          <a:p>
+            <a:pPr algn="ctr"/>
+            <a:r>
+              <a:rPr sz="2200" b="0" i="0">
+                <a:solidFill>
+                  <a:srgbClr val="DEE2E6"/>
+                </a:solidFill>
+              </a:rPr>
+              <a:t>Game Programming Patterns</a:t>
+            </a:r>
+          </a:p>
+        </p:txBody>
+      </p:sp>
+      <p:sp>
+        <p:nvSpPr>
+          <p:cNvPr id="91" name="TextBox 90"/>
+          <p:cNvSpPr txBox="1"/>
+          <p:nvPr/>
+        </p:nvSpPr>
+        <p:spPr>
+          <a:xfrm>
+            <a:off x="457200" y="2468880"/>
+            <a:ext cx="8229600" cy="457200"/>
+          </a:xfrm>
+          <a:prstGeom prst="rect">
+            <a:avLst/>
+          </a:prstGeom>
+          <a:noFill/>
+        </p:spPr>
+        <p:txBody>
+          <a:bodyPr wrap="square">
+            <a:spAutoFit/>
+          </a:bodyPr>
+          <a:lstStyle/>
+          <a:p>
+            <a:pPr algn="ctr"/>
+            <a:r>
+              <a:rPr sz="1800" b="0" i="0">
+                <a:solidFill>
+                  <a:srgbClr val="9AA3AB"/>
+                </a:solidFill>
+              </a:rPr>
+              <a:t>Robert Nystrom</a:t>
+            </a:r>
+          </a:p>
+        </p:txBody>
+      </p:sp>
+    </p:spTree>
+  </p:cSld>
+  <p:clrMapOvr>
+    <a:masterClrMapping/>
+  </p:clrMapOvr>
+</p:sld>
+</file>
+
+<file path=ppt/slides/slide11.xml><?xml version="1.0" encoding="utf-8"?>
 <p:sld xmlns:a="http://schemas.openxmlformats.org/drawingml/2006/main" xmlns:p="http://schemas.openxmlformats.org/presentationml/2006/main" xmlns:r="http://schemas.openxmlformats.org/officeDocument/2006/relationships">
   <p:cSld>
     <p:spTree>
@@ -5658,7 +5779,7 @@
 </p:sld>
 </file>
 
-<file path=ppt/slides/slide11.xml><?xml version="1.0" encoding="utf-8"?>
+<file path=ppt/slides/slide12.xml><?xml version="1.0" encoding="utf-8"?>
 <p:sld xmlns:a="http://schemas.openxmlformats.org/drawingml/2006/main" xmlns:r="http://schemas.openxmlformats.org/officeDocument/2006/relationships" xmlns:mc="http://schemas.openxmlformats.org/markup-compatibility/2006" xmlns:mv="urn:schemas-microsoft-com:mac:vml" xmlns:p="http://schemas.openxmlformats.org/presentationml/2006/main" xmlns:c="http://schemas.openxmlformats.org/drawingml/2006/chart" xmlns:dgm="http://schemas.openxmlformats.org/drawingml/2006/diagram" xmlns:o="urn:schemas-microsoft-com:office:office" xmlns:v="urn:schemas-microsoft-com:vml" xmlns:pvml="urn:schemas-microsoft-com:office:powerpoint" xmlns:com="http://schemas.openxmlformats.org/drawingml/2006/compatibility" xmlns:p14="http://schemas.microsoft.com/office/powerpoint/2010/main" xmlns:p15="http://schemas.microsoft.com/office/powerpoint/2012/main" xmlns:ahyp="http://schemas.microsoft.com/office/drawing/2018/hyperlinkcolor">
   <p:cSld>
     <p:spTree>
@@ -5815,7 +5936,7 @@
 </p:sld>
 </file>
 
-<file path=ppt/slides/slide12.xml><?xml version="1.0" encoding="utf-8"?>
+<file path=ppt/slides/slide13.xml><?xml version="1.0" encoding="utf-8"?>
 <p:sld xmlns:a="http://schemas.openxmlformats.org/drawingml/2006/main" xmlns:r="http://schemas.openxmlformats.org/officeDocument/2006/relationships" xmlns:mc="http://schemas.openxmlformats.org/markup-compatibility/2006" xmlns:mv="urn:schemas-microsoft-com:mac:vml" xmlns:p="http://schemas.openxmlformats.org/presentationml/2006/main" xmlns:c="http://schemas.openxmlformats.org/drawingml/2006/chart" xmlns:dgm="http://schemas.openxmlformats.org/drawingml/2006/diagram" xmlns:o="urn:schemas-microsoft-com:office:office" xmlns:v="urn:schemas-microsoft-com:vml" xmlns:pvml="urn:schemas-microsoft-com:office:powerpoint" xmlns:com="http://schemas.openxmlformats.org/drawingml/2006/compatibility" xmlns:p14="http://schemas.microsoft.com/office/powerpoint/2010/main" xmlns:p15="http://schemas.microsoft.com/office/powerpoint/2012/main" xmlns:ahyp="http://schemas.microsoft.com/office/drawing/2018/hyperlinkcolor">
   <p:cSld>
     <p:spTree>
@@ -6298,7 +6419,7 @@
 </p:sld>
 </file>
 
-<file path=ppt/slides/slide13.xml><?xml version="1.0" encoding="utf-8"?>
+<file path=ppt/slides/slide14.xml><?xml version="1.0" encoding="utf-8"?>
 <p:sld xmlns:a="http://schemas.openxmlformats.org/drawingml/2006/main" xmlns:p="http://schemas.openxmlformats.org/presentationml/2006/main" xmlns:r="http://schemas.openxmlformats.org/officeDocument/2006/relationships">
   <p:cSld>
     <p:spTree>
@@ -6674,58 +6795,115 @@
 </p:sld>
 </file>
 
-<file path=ppt/slides/slide3.xml><?xml version="1.0" encoding="utf-8"?>
-<p:sld xmlns:a="http://schemas.openxmlformats.org/drawingml/2006/main" xmlns:r="http://schemas.openxmlformats.org/officeDocument/2006/relationships" xmlns:mc="http://schemas.openxmlformats.org/markup-compatibility/2006" xmlns:mv="urn:schemas-microsoft-com:mac:vml" xmlns:p="http://schemas.openxmlformats.org/presentationml/2006/main" xmlns:c="http://schemas.openxmlformats.org/drawingml/2006/chart" xmlns:dgm="http://schemas.openxmlformats.org/drawingml/2006/diagram" xmlns:o="urn:schemas-microsoft-com:office:office" xmlns:v="urn:schemas-microsoft-com:vml" xmlns:pvml="urn:schemas-microsoft-com:office:powerpoint" xmlns:com="http://schemas.openxmlformats.org/drawingml/2006/compatibility" xmlns:p14="http://schemas.microsoft.com/office/powerpoint/2010/main" xmlns:p15="http://schemas.microsoft.com/office/powerpoint/2012/main" xmlns:ahyp="http://schemas.microsoft.com/office/drawing/2018/hyperlinkcolor">
+<file path=ppt/slides/slide4.xml><?xml version="1.0" encoding="utf-8"?>
+<p:sld xmlns:a="http://schemas.openxmlformats.org/drawingml/2006/main" xmlns:p="http://schemas.openxmlformats.org/presentationml/2006/main" xmlns:r="http://schemas.openxmlformats.org/officeDocument/2006/relationships">
   <p:cSld>
     <p:spTree>
       <p:nvGrpSpPr>
-        <p:cNvPr id="52" name="Shape 52"/>
+        <p:cNvPr id="1" name=""/>
         <p:cNvGrpSpPr/>
         <p:nvPr/>
       </p:nvGrpSpPr>
-      <p:grpSpPr>
-        <a:xfrm>
-          <a:off x="0" y="0"/>
-          <a:ext cx="0" cy="0"/>
-          <a:chOff x="0" y="0"/>
-          <a:chExt cx="0" cy="0"/>
-        </a:xfrm>
-      </p:grpSpPr>
+      <p:grpSpPr/>
       <p:sp>
         <p:nvSpPr>
-          <p:cNvPr id="53" name="Google Shape;53;p11"/>
-          <p:cNvSpPr txBox="1"/>
+          <p:cNvPr id="2" name="Title 1"/>
+          <p:cNvSpPr>
+            <a:spLocks noGrp="1"/>
+          </p:cNvSpPr>
           <p:nvPr>
             <p:ph type="title"/>
           </p:nvPr>
         </p:nvSpPr>
+        <p:spPr/>
+        <p:txBody>
+          <a:bodyPr/>
+          <a:lstStyle/>
+          <a:p>
+            <a:pPr indent="0" lvl="0" marL="0" rtl="0" algn="l">
+              <a:spcBef>
+                <a:spcPts val="0"/>
+              </a:spcBef>
+              <a:spcAft>
+                <a:spcPts val="0"/>
+              </a:spcAft>
+              <a:buNone/>
+            </a:pPr>
+            <a:r>
+              <a:rPr lang="en"/>
+              <a:t>Who Are You?</a:t>
+            </a:r>
+            <a:endParaRPr/>
+          </a:p>
+        </p:txBody>
+      </p:sp>
+      <p:sp>
+        <p:nvSpPr>
+          <p:cNvPr id="3" name="Text Placeholder 2"/>
+          <p:cNvSpPr>
+            <a:spLocks noGrp="1"/>
+          </p:cNvSpPr>
+          <p:nvPr>
+            <p:ph type="body" idx="1"/>
+          </p:nvPr>
+        </p:nvSpPr>
         <p:spPr>
           <a:xfrm>
-            <a:off x="311700" y="195615"/>
-            <a:ext cx="8520600" cy="572700"/>
+            <a:off x="311700" y="885950"/>
+            <a:ext cx="8520600" cy="1289304"/>
           </a:xfrm>
-          <a:prstGeom prst="rect">
-            <a:avLst/>
-          </a:prstGeom>
         </p:spPr>
         <p:txBody>
-          <a:bodyPr anchorCtr="0" anchor="t" bIns="91425" lIns="91425" spcFirstLastPara="1" rIns="91425" wrap="square" tIns="91425">
-            <a:normAutofit fontScale="90000"/>
-          </a:bodyPr>
+          <a:bodyPr/>
           <a:lstStyle/>
           <a:p>
-            <a:pPr indent="0" lvl="0" marL="0" rtl="0" algn="l">
-              <a:spcBef>
-                <a:spcPts val="0"/>
-              </a:spcBef>
-              <a:spcAft>
-                <a:spcPts val="0"/>
-              </a:spcAft>
-              <a:buNone/>
+            <a:pPr indent="-330200" lvl="0" marL="457200" rtl="0" algn="l">
+              <a:spcBef>
+                <a:spcPts val="0"/>
+              </a:spcBef>
+              <a:spcAft>
+                <a:spcPts val="0"/>
+              </a:spcAft>
+              <a:buSzPts val="1600"/>
+              <a:buChar char="●"/>
             </a:pPr>
             <a:r>
               <a:rPr lang="en"/>
-              <a:t>Who Are You?</a:t>
+              <a:t>Your name, and what you study</a:t>
+            </a:r>
+            <a:endParaRPr/>
+          </a:p>
+          <a:p>
+            <a:pPr indent="-330200" lvl="0" marL="457200" rtl="0" algn="l">
+              <a:spcBef>
+                <a:spcPts val="0"/>
+              </a:spcBef>
+              <a:spcAft>
+                <a:spcPts val="0"/>
+              </a:spcAft>
+              <a:buSzPts val="1600"/>
+              <a:buChar char="●"/>
+            </a:pPr>
+            <a:r>
+              <a:rPr lang="en"/>
+              <a:t>A game you have played a lot</a:t>
+            </a:r>
+            <a:endParaRPr/>
+          </a:p>
+          <a:p>
+            <a:pPr indent="-330200" lvl="0" marL="457200" rtl="0" algn="l">
+              <a:spcBef>
+                <a:spcPts val="0"/>
+              </a:spcBef>
+              <a:spcAft>
+                <a:spcPts val="0"/>
+              </a:spcAft>
+              <a:buSzPts val="1600"/>
+              <a:buChar char="●"/>
+            </a:pPr>
+            <a:r>
+              <a:rPr lang="en"/>
+              <a:t>Have you made a game before?</a:t>
             </a:r>
             <a:endParaRPr/>
           </a:p>
@@ -6739,7 +6917,7 @@
 </p:sld>
 </file>
 
-<file path=ppt/slides/slide4.xml><?xml version="1.0" encoding="utf-8"?>
+<file path=ppt/slides/slide5.xml><?xml version="1.0" encoding="utf-8"?>
 <p:sld xmlns:a="http://schemas.openxmlformats.org/drawingml/2006/main" xmlns:r="http://schemas.openxmlformats.org/officeDocument/2006/relationships" xmlns:mc="http://schemas.openxmlformats.org/markup-compatibility/2006" xmlns:mv="urn:schemas-microsoft-com:mac:vml" xmlns:p="http://schemas.openxmlformats.org/presentationml/2006/main" xmlns:c="http://schemas.openxmlformats.org/drawingml/2006/chart" xmlns:dgm="http://schemas.openxmlformats.org/drawingml/2006/diagram" xmlns:o="urn:schemas-microsoft-com:office:office" xmlns:v="urn:schemas-microsoft-com:vml" xmlns:pvml="urn:schemas-microsoft-com:office:powerpoint" xmlns:com="http://schemas.openxmlformats.org/drawingml/2006/compatibility" xmlns:p14="http://schemas.microsoft.com/office/powerpoint/2010/main" xmlns:p15="http://schemas.microsoft.com/office/powerpoint/2012/main" xmlns:ahyp="http://schemas.microsoft.com/office/drawing/2018/hyperlinkcolor">
   <p:cSld>
     <p:spTree>
@@ -6804,7 +6982,7 @@
 </p:sld>
 </file>
 
-<file path=ppt/slides/slide5.xml><?xml version="1.0" encoding="utf-8"?>
+<file path=ppt/slides/slide6.xml><?xml version="1.0" encoding="utf-8"?>
 <p:sld xmlns:a="http://schemas.openxmlformats.org/drawingml/2006/main" xmlns:r="http://schemas.openxmlformats.org/officeDocument/2006/relationships" xmlns:mc="http://schemas.openxmlformats.org/markup-compatibility/2006" xmlns:mv="urn:schemas-microsoft-com:mac:vml" xmlns:p="http://schemas.openxmlformats.org/presentationml/2006/main" xmlns:c="http://schemas.openxmlformats.org/drawingml/2006/chart" xmlns:dgm="http://schemas.openxmlformats.org/drawingml/2006/diagram" xmlns:o="urn:schemas-microsoft-com:office:office" xmlns:v="urn:schemas-microsoft-com:vml" xmlns:pvml="urn:schemas-microsoft-com:office:powerpoint" xmlns:com="http://schemas.openxmlformats.org/drawingml/2006/compatibility" xmlns:p14="http://schemas.microsoft.com/office/powerpoint/2010/main" xmlns:p15="http://schemas.microsoft.com/office/powerpoint/2012/main" xmlns:ahyp="http://schemas.microsoft.com/office/drawing/2018/hyperlinkcolor">
   <p:cSld>
     <p:spTree>
@@ -6941,7 +7119,7 @@
 </p:sld>
 </file>
 
-<file path=ppt/slides/slide6.xml><?xml version="1.0" encoding="utf-8"?>
+<file path=ppt/slides/slide7.xml><?xml version="1.0" encoding="utf-8"?>
 <p:sld xmlns:a="http://schemas.openxmlformats.org/drawingml/2006/main" xmlns:r="http://schemas.openxmlformats.org/officeDocument/2006/relationships" xmlns:mc="http://schemas.openxmlformats.org/markup-compatibility/2006" xmlns:mv="urn:schemas-microsoft-com:mac:vml" xmlns:p="http://schemas.openxmlformats.org/presentationml/2006/main" xmlns:c="http://schemas.openxmlformats.org/drawingml/2006/chart" xmlns:dgm="http://schemas.openxmlformats.org/drawingml/2006/diagram" xmlns:o="urn:schemas-microsoft-com:office:office" xmlns:v="urn:schemas-microsoft-com:vml" xmlns:pvml="urn:schemas-microsoft-com:office:powerpoint" xmlns:com="http://schemas.openxmlformats.org/drawingml/2006/compatibility" xmlns:p14="http://schemas.microsoft.com/office/powerpoint/2010/main" xmlns:p15="http://schemas.microsoft.com/office/powerpoint/2012/main" xmlns:ahyp="http://schemas.microsoft.com/office/drawing/2018/hyperlinkcolor">
   <p:cSld>
     <p:spTree>
@@ -7132,7 +7310,7 @@
 </p:sld>
 </file>
 
-<file path=ppt/slides/slide7.xml><?xml version="1.0" encoding="utf-8"?>
+<file path=ppt/slides/slide8.xml><?xml version="1.0" encoding="utf-8"?>
 <p:sld xmlns:a="http://schemas.openxmlformats.org/drawingml/2006/main" xmlns:r="http://schemas.openxmlformats.org/officeDocument/2006/relationships" xmlns:mc="http://schemas.openxmlformats.org/markup-compatibility/2006" xmlns:mv="urn:schemas-microsoft-com:mac:vml" xmlns:p="http://schemas.openxmlformats.org/presentationml/2006/main" xmlns:c="http://schemas.openxmlformats.org/drawingml/2006/chart" xmlns:dgm="http://schemas.openxmlformats.org/drawingml/2006/diagram" xmlns:o="urn:schemas-microsoft-com:office:office" xmlns:v="urn:schemas-microsoft-com:vml" xmlns:pvml="urn:schemas-microsoft-com:office:powerpoint" xmlns:com="http://schemas.openxmlformats.org/drawingml/2006/compatibility" xmlns:p14="http://schemas.microsoft.com/office/powerpoint/2010/main" xmlns:p15="http://schemas.microsoft.com/office/powerpoint/2012/main" xmlns:ahyp="http://schemas.microsoft.com/office/drawing/2018/hyperlinkcolor">
   <p:cSld>
     <p:spTree>
@@ -7442,7 +7620,7 @@
 </p:sld>
 </file>
 
-<file path=ppt/slides/slide8.xml><?xml version="1.0" encoding="utf-8"?>
+<file path=ppt/slides/slide9.xml><?xml version="1.0" encoding="utf-8"?>
 <p:sld xmlns:a="http://schemas.openxmlformats.org/drawingml/2006/main" xmlns:r="http://schemas.openxmlformats.org/officeDocument/2006/relationships" xmlns:mc="http://schemas.openxmlformats.org/markup-compatibility/2006" xmlns:mv="urn:schemas-microsoft-com:mac:vml" xmlns:p="http://schemas.openxmlformats.org/presentationml/2006/main" xmlns:c="http://schemas.openxmlformats.org/drawingml/2006/chart" xmlns:dgm="http://schemas.openxmlformats.org/drawingml/2006/diagram" xmlns:o="urn:schemas-microsoft-com:office:office" xmlns:v="urn:schemas-microsoft-com:vml" xmlns:pvml="urn:schemas-microsoft-com:office:powerpoint" xmlns:com="http://schemas.openxmlformats.org/drawingml/2006/compatibility" xmlns:p14="http://schemas.microsoft.com/office/powerpoint/2010/main" xmlns:p15="http://schemas.microsoft.com/office/powerpoint/2012/main" xmlns:ahyp="http://schemas.microsoft.com/office/drawing/2018/hyperlinkcolor">
   <p:cSld>
     <p:spTree>
@@ -7724,158 +7902,6 @@
               <a:t>Vampire Survivors</a:t>
             </a:r>
             <a:endParaRPr/>
-          </a:p>
-        </p:txBody>
-      </p:sp>
-    </p:spTree>
-  </p:cSld>
-  <p:clrMapOvr>
-    <a:masterClrMapping/>
-  </p:clrMapOvr>
-</p:sld>
-</file>
-
-<file path=ppt/slides/slide9.xml><?xml version="1.0" encoding="utf-8"?>
-<p:sld xmlns:a="http://schemas.openxmlformats.org/drawingml/2006/main" xmlns:r="http://schemas.openxmlformats.org/officeDocument/2006/relationships" xmlns:mc="http://schemas.openxmlformats.org/markup-compatibility/2006" xmlns:mv="urn:schemas-microsoft-com:mac:vml" xmlns:p="http://schemas.openxmlformats.org/presentationml/2006/main" xmlns:c="http://schemas.openxmlformats.org/drawingml/2006/chart" xmlns:dgm="http://schemas.openxmlformats.org/drawingml/2006/diagram" xmlns:o="urn:schemas-microsoft-com:office:office" xmlns:v="urn:schemas-microsoft-com:vml" xmlns:pvml="urn:schemas-microsoft-com:office:powerpoint" xmlns:com="http://schemas.openxmlformats.org/drawingml/2006/compatibility" xmlns:p14="http://schemas.microsoft.com/office/powerpoint/2010/main" xmlns:p15="http://schemas.microsoft.com/office/powerpoint/2012/main" xmlns:ahyp="http://schemas.microsoft.com/office/drawing/2018/hyperlinkcolor">
-  <p:cSld>
-    <p:spTree>
-      <p:nvGrpSpPr>
-        <p:cNvPr id="87" name="Shape 87"/>
-        <p:cNvGrpSpPr/>
-        <p:nvPr/>
-      </p:nvGrpSpPr>
-      <p:grpSpPr>
-        <a:xfrm>
-          <a:off x="0" y="0"/>
-          <a:ext cx="0" cy="0"/>
-          <a:chOff x="0" y="0"/>
-          <a:chExt cx="0" cy="0"/>
-        </a:xfrm>
-      </p:grpSpPr>
-      <p:sp>
-        <p:nvSpPr>
-          <p:cNvPr id="89" name="Google Shape;89;p17"/>
-          <p:cNvSpPr txBox="1"/>
-          <p:nvPr/>
-        </p:nvSpPr>
-        <p:spPr>
-          <a:xfrm>
-            <a:off x="3013800" y="4453575"/>
-            <a:ext cx="3116400" cy="391200"/>
-          </a:xfrm>
-          <a:prstGeom prst="rect">
-            <a:avLst/>
-          </a:prstGeom>
-          <a:noFill/>
-          <a:ln>
-            <a:noFill/>
-          </a:ln>
-        </p:spPr>
-        <p:txBody>
-          <a:bodyPr anchorCtr="0" anchor="t" bIns="91425" lIns="91425" spcFirstLastPara="1" rIns="91425" wrap="square" tIns="91425">
-            <a:noAutofit/>
-          </a:bodyPr>
-          <a:lstStyle/>
-          <a:p>
-            <a:pPr indent="0" lvl="0" marL="0" rtl="0" algn="ctr">
-              <a:spcBef>
-                <a:spcPts val="0"/>
-              </a:spcBef>
-              <a:spcAft>
-                <a:spcPts val="0"/>
-              </a:spcAft>
-              <a:buNone/>
-            </a:pPr>
-            <a:r>
-              <a:rPr lang="en" u="sng">
-                <a:solidFill>
-                  <a:schemeClr val="hlink"/>
-                </a:solidFill>
-                <a:latin typeface="Roboto Light"/>
-                <a:ea typeface="Roboto Light"/>
-                <a:cs typeface="Roboto Light"/>
-                <a:sym typeface="Roboto Light"/>
-                <a:hlinkClick r:id="rId4"/>
-              </a:rPr>
-              <a:t>gameprogrammingpatterns.com</a:t>
-            </a:r>
-            <a:endParaRPr>
-              <a:solidFill>
-                <a:schemeClr val="dk1"/>
-              </a:solidFill>
-              <a:latin typeface="Roboto Light"/>
-              <a:ea typeface="Roboto Light"/>
-              <a:cs typeface="Roboto Light"/>
-              <a:sym typeface="Roboto Light"/>
-            </a:endParaRPr>
-          </a:p>
-        </p:txBody>
-      </p:sp>
-      <p:sp>
-        <p:nvSpPr>
-          <p:cNvPr id="90" name="TextBox 89"/>
-          <p:cNvSpPr txBox="1"/>
-          <p:nvPr/>
-        </p:nvSpPr>
-        <p:spPr>
-          <a:xfrm>
-            <a:off x="457200" y="1920240"/>
-            <a:ext cx="8229600" cy="457200"/>
-          </a:xfrm>
-          <a:prstGeom prst="rect">
-            <a:avLst/>
-          </a:prstGeom>
-          <a:noFill/>
-        </p:spPr>
-        <p:txBody>
-          <a:bodyPr wrap="square">
-            <a:spAutoFit/>
-          </a:bodyPr>
-          <a:lstStyle/>
-          <a:p>
-            <a:pPr algn="ctr"/>
-            <a:r>
-              <a:rPr sz="2200" b="0" i="0">
-                <a:solidFill>
-                  <a:srgbClr val="DEE2E6"/>
-                </a:solidFill>
-              </a:rPr>
-              <a:t>Game Programming Patterns</a:t>
-            </a:r>
-          </a:p>
-        </p:txBody>
-      </p:sp>
-      <p:sp>
-        <p:nvSpPr>
-          <p:cNvPr id="91" name="TextBox 90"/>
-          <p:cNvSpPr txBox="1"/>
-          <p:nvPr/>
-        </p:nvSpPr>
-        <p:spPr>
-          <a:xfrm>
-            <a:off x="457200" y="2468880"/>
-            <a:ext cx="8229600" cy="457200"/>
-          </a:xfrm>
-          <a:prstGeom prst="rect">
-            <a:avLst/>
-          </a:prstGeom>
-          <a:noFill/>
-        </p:spPr>
-        <p:txBody>
-          <a:bodyPr wrap="square">
-            <a:spAutoFit/>
-          </a:bodyPr>
-          <a:lstStyle/>
-          <a:p>
-            <a:pPr algn="ctr"/>
-            <a:r>
-              <a:rPr sz="1800" b="0" i="0">
-                <a:solidFill>
-                  <a:srgbClr val="9AA3AB"/>
-                </a:solidFill>
-              </a:rPr>
-              <a:t>Robert Nystrom</a:t>
-            </a:r>
           </a:p>
         </p:txBody>
       </p:sp>

</xml_diff>